<commit_message>
Make VeilIntent verifiable in one short judge session
Lead the public demo with the recorded 150-unit escrow, seller 100 payout, and buyer 50 remainder. Add an interactive seven-receipt replay while labeling the browser policy checker as simulation. Align the deck and submission copy with the same evidence and privacy boundaries.

Constraint: The site is a static Local Devnet evidence viewer, not a live wallet, AI agent, or atomic swap.

Rejected: Present the policy checker as a Compact proof | it only compares values in the browser.

Confidence: high

Scope-risk: moderate

Tested: 60 repository tests and 14 VeilIntent tests; desktop and 390px browser checks; Pages build and live receipt load; six-slide render and PPTX integrity.

Not-tested: Preprod payment, independent agent service, customer demand, or live browser transaction.
</commit_message>
<xml_diff>
--- a/artifacts/output/VeilIntent-Midnight-Korea-Hackathon-2026.pptx
+++ b/artifacts/output/VeilIntent-Midnight-Korea-Hackathon-2026.pptx
@@ -2,18 +2,18 @@
 <file path=ppt/presentation.xml><?xml version="1.0" encoding="utf-8"?>
 <p:presentation xmlns:p="http://schemas.openxmlformats.org/presentationml/2006/main">
   <p:sldMasterIdLst>
-    <p:sldMasterId xmlns:r="http://schemas.openxmlformats.org/officeDocument/2006/relationships" id="2147483648" r:id="Rad6ea2bc7bca4d23"/>
+    <p:sldMasterId xmlns:r="http://schemas.openxmlformats.org/officeDocument/2006/relationships" id="2147483648" r:id="Rb90285f3dc9a4e36"/>
   </p:sldMasterIdLst>
   <p:notesMasterIdLst>
-    <p:notesMasterId xmlns:r="http://schemas.openxmlformats.org/officeDocument/2006/relationships" r:id="R6be7ac4e2d3c4c8d"/>
+    <p:notesMasterId xmlns:r="http://schemas.openxmlformats.org/officeDocument/2006/relationships" r:id="R216228eb9a6b4434"/>
   </p:notesMasterIdLst>
   <p:sldIdLst>
-    <p:sldId xmlns:r="http://schemas.openxmlformats.org/officeDocument/2006/relationships" id="256" r:id="Rd94ff2db7211430b"/>
-    <p:sldId xmlns:r="http://schemas.openxmlformats.org/officeDocument/2006/relationships" id="257" r:id="R9850affce22c4120"/>
-    <p:sldId xmlns:r="http://schemas.openxmlformats.org/officeDocument/2006/relationships" id="258" r:id="Rfc321af6b7f04531"/>
-    <p:sldId xmlns:r="http://schemas.openxmlformats.org/officeDocument/2006/relationships" id="259" r:id="R76f441b9d17346d1"/>
-    <p:sldId xmlns:r="http://schemas.openxmlformats.org/officeDocument/2006/relationships" id="260" r:id="Re84f73790b144ed6"/>
-    <p:sldId xmlns:r="http://schemas.openxmlformats.org/officeDocument/2006/relationships" id="261" r:id="R2dd79aa329f649dd"/>
+    <p:sldId xmlns:r="http://schemas.openxmlformats.org/officeDocument/2006/relationships" id="256" r:id="Rc000a6ada74c42d0"/>
+    <p:sldId xmlns:r="http://schemas.openxmlformats.org/officeDocument/2006/relationships" id="257" r:id="Re7b19664b4a84c66"/>
+    <p:sldId xmlns:r="http://schemas.openxmlformats.org/officeDocument/2006/relationships" id="258" r:id="R5d81a5721d41480c"/>
+    <p:sldId xmlns:r="http://schemas.openxmlformats.org/officeDocument/2006/relationships" id="259" r:id="R1202db9c177f45c9"/>
+    <p:sldId xmlns:r="http://schemas.openxmlformats.org/officeDocument/2006/relationships" id="260" r:id="Rf043ac6bb82b4d6b"/>
+    <p:sldId xmlns:r="http://schemas.openxmlformats.org/officeDocument/2006/relationships" id="261" r:id="R79f8c7b790344630"/>
   </p:sldIdLst>
   <p:sldSz cx="12192000" cy="6858000"/>
   <p:notesSz cx="6858000" cy="9144000"/>
@@ -537,7 +537,7 @@
           </a:p>
           <a:p xmlns:a="http://schemas.openxmlformats.org/drawingml/2006/main">
             <a:r>
-              <a:t>Latch's August 2026 winner description already centers private AI-agent spending policies. VeilIntent should differentiate on the verifiable trade: seller quote stays public, buyer reservation price stays a witness, and the chain completes the seller payment plus buyer change. This is a narrower evidence-backed claim, not proof of novel customer demand.</a:t>
+              <a:t>The buyer ceiling means the maximum unit price and total spend accepted for one intent. The potential treasury/agent user and strategy-privacy need are a market hypothesis, not customer-validated. The verified Local Devnet payment is separate from that hypothesis.</a:t>
             </a:r>
           </a:p>
           <a:p xmlns:a="http://schemas.openxmlformats.org/drawingml/2006/main">
@@ -792,7 +792,7 @@
           </a:p>
           <a:p xmlns:a="http://schemas.openxmlformats.org/drawingml/2006/main">
             <a:r>
-              <a:t>실제 영수증 7건은 block 4222–4246에 확정됐고 독립 indexer 대조 7/7, 새 프로세스 지갑 readback seller100/buyer50을 확인했습니다. 이 테스트 자산으로 seller 상품 전달까지 하지는 않았습니다.</a:t>
+              <a:t>The site interactively replays seven already finalized Local Devnet receipts; it submits no transaction. The seven steps run from block 4222 through 4246. An independent indexer checked all seven receipts, and a separate process re-read seller 100 and buyer 50 wallet balances. These are valueless test tokens.</a:t>
             </a:r>
           </a:p>
           <a:p xmlns:a="http://schemas.openxmlformats.org/drawingml/2006/main">
@@ -877,7 +877,7 @@
           </a:p>
           <a:p xmlns:a="http://schemas.openxmlformats.org/drawingml/2006/main">
             <a:r>
-              <a:t>Agent는 LLM이 아니라 test role입니다. Approval circuit은 buyer seed를 받지 않지만 runner는 세 역할 seed를 한 process에 들고 buyer genesis가 DUST를 냈습니다. 공개 quote와 escrow는 cap 범위를 드러냅니다. Atomic swap, independent agent service, browser/Preprod, reusable daily cap, customer PMF는 미검증입니다.</a:t>
+              <a:t>The agent is a deterministic test prover, not an LLM; AI-generated intents are future work. The public site replays recorded evidence and offers a separate browser-only simulation, with no live wallet, proof, or transaction. The verified path is one-way payment only. Treasury/agent demand, independent services, atomic swap, seller delivery, browser wallet, and Preprod remain unverified.</a:t>
             </a:r>
           </a:p>
           <a:p xmlns:a="http://schemas.openxmlformats.org/drawingml/2006/main">
@@ -955,7 +955,7 @@
   </p:cSld>
   <p:clrMap bg1="lt1" tx1="dk1" bg2="lt2" tx2="dk2" accent1="accent1" accent2="accent2" accent3="accent3" accent4="accent4" accent5="accent5" accent6="accent6" hlink="hlink" folHlink="folHlink"/>
   <p:sldLayoutIdLst>
-    <p:sldLayoutId xmlns:r="http://schemas.openxmlformats.org/officeDocument/2006/relationships" id="2147483649" r:id="R8ae43ef8b53b45f6"/>
+    <p:sldLayoutId xmlns:r="http://schemas.openxmlformats.org/officeDocument/2006/relationships" id="2147483649" r:id="Rdfd66a61eff24c19"/>
   </p:sldLayoutIdLst>
   <p:txStyles>
     <p:titleStyle>
@@ -1787,7 +1787,7 @@
                 <a:ea typeface="Arial"/>
                 <a:cs typeface="Arial"/>
               </a:rPr>
-              <a:t>Buyer reservation-price privacy for one seller quote</a:t>
+              <a:t>A public seller quote checked against private per-intent price and budget limits</a:t>
             </a:r>
           </a:p>
         </p:txBody>
@@ -1846,7 +1846,7 @@
                 <a:ea typeface="Arial"/>
                 <a:cs typeface="Arial"/>
               </a:rPr>
-              <a:t>One-way Local Devnet test-token payment · simulated agent role · not an atomic swap</a:t>
+              <a:t>Recorded valueless Local Devnet payment · no live wallet or AI · no atomic asset swap</a:t>
             </a:r>
           </a:p>
         </p:txBody>
@@ -2201,7 +2201,7 @@
                 <a:ea typeface="Arial"/>
                 <a:cs typeface="Arial"/>
               </a:rPr>
-              <a:t>Private Buyer Cap</a:t>
+              <a:t>Buyer Ceiling</a:t>
             </a:r>
           </a:p>
         </p:txBody>
@@ -2291,7 +2291,7 @@
                 <a:ea typeface="Arial"/>
                 <a:cs typeface="Arial"/>
               </a:rPr>
-              <a:t>Maximum unit price and total budget stay with the prover.</a:t>
+              <a:t>The buyer’s maximum unit price and total spend for this intent stay with the prover.</a:t>
             </a:r>
           </a:p>
         </p:txBody>
@@ -2679,7 +2679,7 @@
                 <a:ea typeface="Arial"/>
                 <a:cs typeface="Arial"/>
               </a:rPr>
-              <a:t>Can a public seller quote be checked against the buyer's hidden reservation price?</a:t>
+              <a:t>Can a public quote be checked against that ceiling without revealing its exact values?</a:t>
             </a:r>
           </a:p>
         </p:txBody>
@@ -2701,7 +2701,7 @@
         <p:spPr>
           <a:xfrm xmlns:a="http://schemas.openxmlformats.org/drawingml/2006/main">
             <a:off x="723900" y="5524500"/>
-            <a:ext cx="10706100" cy="266700"/>
+            <a:ext cx="10706100" cy="647700"/>
           </a:xfrm>
           <a:prstGeom xmlns:a="http://schemas.openxmlformats.org/drawingml/2006/main" prst="rect">
             <a:avLst/>
@@ -2738,7 +2738,8 @@
                 <a:ea typeface="Arial"/>
                 <a:cs typeface="Arial"/>
               </a:rPr>
-              <a:t>VeilIntent's tested wedge: quote-to-cap check, seller 100 payment, and buyer 50 change. Customer demand is untested.</a:t>
+              <a:t>Market hypothesis (untested): treasury and agent operators may want to protect reservation prices.
+Verified on Local Devnet: one quote-to-cap check; seller 100, buyer change 50.</a:t>
             </a:r>
           </a:p>
         </p:txBody>
@@ -3489,7 +3490,7 @@
       </p:sp>
       <p:cxnSp>
         <p:nvCxnSpPr>
-          <p:cNvPr id="61" name=""/>
+          <p:cNvPr id="73" name=""/>
           <p:cNvCxnSpPr>
             <a:stCxn xmlns:a="http://schemas.openxmlformats.org/drawingml/2006/main" id="6" idx="3"/>
             <a:endCxn xmlns:a="http://schemas.openxmlformats.org/drawingml/2006/main" id="7" idx="1"/>
@@ -3515,7 +3516,7 @@
       </p:cxnSp>
       <p:cxnSp>
         <p:nvCxnSpPr>
-          <p:cNvPr id="62" name=""/>
+          <p:cNvPr id="74" name=""/>
           <p:cNvCxnSpPr>
             <a:stCxn xmlns:a="http://schemas.openxmlformats.org/drawingml/2006/main" id="7" idx="3"/>
             <a:endCxn xmlns:a="http://schemas.openxmlformats.org/drawingml/2006/main" id="8" idx="1"/>
@@ -3541,7 +3542,7 @@
       </p:cxnSp>
       <p:cxnSp>
         <p:nvCxnSpPr>
-          <p:cNvPr id="63" name=""/>
+          <p:cNvPr id="75" name=""/>
           <p:cNvCxnSpPr>
             <a:stCxn xmlns:a="http://schemas.openxmlformats.org/drawingml/2006/main" id="8" idx="3"/>
             <a:endCxn xmlns:a="http://schemas.openxmlformats.org/drawingml/2006/main" id="9" idx="1"/>
@@ -3797,7 +3798,7 @@
                 <a:ea typeface="Arial"/>
                 <a:cs typeface="Arial"/>
               </a:rPr>
-              <a:t>Compact Checks Private Spending Caps</a:t>
+              <a:t>Compact Checks the Buyer Ceiling</a:t>
             </a:r>
           </a:p>
         </p:txBody>
@@ -4564,7 +4565,7 @@
                 <a:ea typeface="Arial"/>
                 <a:cs typeface="Arial"/>
               </a:rPr>
-              <a:t>The 150 lot and 100 quote reveal a range for the private cap. Public-ledger field checks are not a raw-transaction, timing, or recipient privacy audit.</a:t>
+              <a:t>Ceiling = the buyer’s max unit price and total spend for one intent. Public lot 150 and quote 100 narrow its possible range; this is scoped field privacy, not full transaction anonymity.</a:t>
             </a:r>
           </a:p>
         </p:txBody>
@@ -4860,7 +4861,7 @@
                 <a:ea typeface="Arial"/>
                 <a:cs typeface="Arial"/>
               </a:rPr>
-              <a:t>Valueless shielded test token · actual receipt path · separate indexer check 7/7</a:t>
+              <a:t>Interactive replay of 7 recorded Local Devnet receipts · not a live transaction</a:t>
             </a:r>
           </a:p>
         </p:txBody>
@@ -6156,7 +6157,7 @@
                 <a:ea typeface="Arial"/>
                 <a:cs typeface="Arial"/>
               </a:rPr>
-              <a:t>The 150 lot and quote are public. The seller does not escrow or deliver a second asset.</a:t>
+              <a:t>Valueless test tokens; the seller does not escrow or deliver a second asset.</a:t>
             </a:r>
           </a:p>
         </p:txBody>
@@ -6542,7 +6543,7 @@
                 <a:ea typeface="Arial"/>
                 <a:cs typeface="Arial"/>
               </a:rPr>
-              <a:t>No LLM or generated orders.</a:t>
+              <a:t>Today: deterministic test prover, not an LLM.</a:t>
             </a:r>
           </a:p>
           <a:p xmlns:a="http://schemas.openxmlformats.org/drawingml/2006/main">
@@ -6566,7 +6567,7 @@
                 <a:ea typeface="Arial"/>
                 <a:cs typeface="Arial"/>
               </a:rPr>
-              <a:t>Agent is a test wallet/secret role.</a:t>
+              <a:t>AI-generated intents are future work.</a:t>
             </a:r>
           </a:p>
           <a:p xmlns:a="http://schemas.openxmlformats.org/drawingml/2006/main">
@@ -6619,7 +6620,51 @@
                 <a:ea typeface="Arial"/>
                 <a:cs typeface="Arial"/>
               </a:rPr>
-              <a:t>One process holds buyer/seller/solver test seeds; buyer genesis pays DUST. Independent services are unverified.</a:t>
+              <a:t>One process held buyer/seller/solver test seeds;</a:t>
+            </a:r>
+            <a:r>
+              <a:rPr sz="1425" b="0">
+                <a:solidFill>
+                  <a:srgbClr val="F1F4FF"/>
+                </a:solidFill>
+                <a:latin typeface="Arial"/>
+                <a:ea typeface="Arial"/>
+                <a:cs typeface="Arial"/>
+              </a:rPr>
+              <a:t> </a:t>
+            </a:r>
+            <a:r>
+              <a:rPr sz="1425" b="0">
+                <a:solidFill>
+                  <a:srgbClr val="F1F4FF"/>
+                </a:solidFill>
+                <a:latin typeface="Arial"/>
+                <a:ea typeface="Arial"/>
+                <a:cs typeface="Arial"/>
+              </a:rPr>
+              <a:t>buyer genesis paid DUST.</a:t>
+            </a:r>
+            <a:r>
+              <a:rPr sz="1425" b="0">
+                <a:solidFill>
+                  <a:srgbClr val="F1F4FF"/>
+                </a:solidFill>
+                <a:latin typeface="Arial"/>
+                <a:ea typeface="Arial"/>
+                <a:cs typeface="Arial"/>
+              </a:rPr>
+              <a:t> </a:t>
+            </a:r>
+            <a:r>
+              <a:rPr sz="1425" b="0">
+                <a:solidFill>
+                  <a:srgbClr val="F1F4FF"/>
+                </a:solidFill>
+                <a:latin typeface="Arial"/>
+                <a:ea typeface="Arial"/>
+                <a:cs typeface="Arial"/>
+              </a:rPr>
+              <a:t>Independent services remain unverified.</a:t>
             </a:r>
           </a:p>
         </p:txBody>
@@ -6946,7 +6991,29 @@
                 <a:ea typeface="Arial"/>
                 <a:cs typeface="Arial"/>
               </a:rPr>
-              <a:t>One-way payment, not atomic swap or seller asset delivery. One quote per intent; rejection needs cancel + new intent. No reusable daily limit.</a:t>
+              <a:t>One-way payment, not atomic swap or seller asset delivery. </a:t>
+            </a:r>
+            <a:r>
+              <a:rPr sz="1425" b="0">
+                <a:solidFill>
+                  <a:srgbClr val="F1F4FF"/>
+                </a:solidFill>
+                <a:latin typeface="Arial"/>
+                <a:ea typeface="Arial"/>
+                <a:cs typeface="Arial"/>
+              </a:rPr>
+              <a:t>One quote per intent; a rejected quote needs cancel + new intent.</a:t>
+            </a:r>
+            <a:r>
+              <a:rPr sz="1425" b="0">
+                <a:solidFill>
+                  <a:srgbClr val="F1F4FF"/>
+                </a:solidFill>
+                <a:latin typeface="Arial"/>
+                <a:ea typeface="Arial"/>
+                <a:cs typeface="Arial"/>
+              </a:rPr>
+              <a:t> No reusable daily limit.</a:t>
             </a:r>
           </a:p>
           <a:p xmlns:a="http://schemas.openxmlformats.org/drawingml/2006/main">
@@ -6975,7 +7042,7 @@
                 <a:ea typeface="Arial"/>
                 <a:cs typeface="Arial"/>
               </a:rPr>
-              <a:t>Browser and Preprod unverified. No customer PMF evidence.</a:t>
+              <a:t>The site replays seven receipts; a separate policy check is browser-only simulation. No live wallet, proof, or transaction; Preprod is unverified. Treasury/agent demand is untested.</a:t>
             </a:r>
           </a:p>
         </p:txBody>
@@ -7096,7 +7163,7 @@
                 <a:ea typeface="Arial"/>
                 <a:cs typeface="Arial"/>
               </a:rPr>
-              <a:t>Local proof is a first payment-policy milestone, not evidence of atomic exchange, independent agent custody, customer PMF, or hackathon submission.</a:t>
+              <a:t>Verified Local Devnet payment is one milestone. It does not establish atomic exchange, independent agent custody, treasury/agent demand, or hackathon submission.</a:t>
             </a:r>
           </a:p>
         </p:txBody>

</xml_diff>